<commit_message>
Rebuild the deck and KB slide against the re-captured screens
The three knowledge-base screens were re-shot at the shared 1440x900 viewport,
and both decks embed them. Leaving the committed .pptx and .pdf alone would
have left them holding the old 1440x1000 captures — the same stale-artifact
trap the SOP README already warns about for the PDF.

71 slides, layout audit reports 0 findings, PDF regenerated from the same
.pptx so the two cannot disagree.
</commit_message>
<xml_diff>
--- a/docs/sop/SUCCESS-Bank-Ticketing-SOP.pptx
+++ b/docs/sop/SUCCESS-Bank-Ticketing-SOP.pptx
@@ -4003,7 +4003,7 @@
                 </a:solidFill>
                 <a:latin typeface="Calibri"/>
               </a:rPr>
-              <a:t>Version 1.0  ·  Built at commit f9f9068</a:t>
+              <a:t>Version 1.0  ·  Built at commit 37f71d3</a:t>
             </a:r>
           </a:p>
         </p:txBody>
@@ -50113,7 +50113,7 @@
         <p:spPr>
           <a:xfrm>
             <a:off x="388620" y="1165860"/>
-            <a:ext cx="6958584" cy="4846320"/>
+            <a:ext cx="7726680" cy="4846320"/>
           </a:xfrm>
           <a:prstGeom prst="rect">
             <a:avLst/>
@@ -50165,7 +50165,7 @@
         <p:spPr>
           <a:xfrm>
             <a:off x="411480" y="1188720"/>
-            <a:ext cx="6912864" cy="4800600"/>
+            <a:ext cx="7680960" cy="4800600"/>
           </a:xfrm>
           <a:prstGeom prst="rect">
             <a:avLst/>
@@ -50180,7 +50180,7 @@
         </p:nvSpPr>
         <p:spPr>
           <a:xfrm>
-            <a:off x="1382649" y="3019805"/>
+            <a:off x="1527742" y="3035647"/>
             <a:ext cx="274320" cy="274320"/>
           </a:xfrm>
           <a:prstGeom prst="ellipse">
@@ -50239,7 +50239,7 @@
         </p:nvSpPr>
         <p:spPr>
           <a:xfrm>
-            <a:off x="1382649" y="3319843"/>
+            <a:off x="1527742" y="3369289"/>
             <a:ext cx="274320" cy="274320"/>
           </a:xfrm>
           <a:prstGeom prst="ellipse">
@@ -50298,7 +50298,7 @@
         </p:nvSpPr>
         <p:spPr>
           <a:xfrm>
-            <a:off x="1382649" y="3779740"/>
+            <a:off x="1527742" y="3880073"/>
             <a:ext cx="274320" cy="274320"/>
           </a:xfrm>
           <a:prstGeom prst="ellipse">
@@ -50357,7 +50357,7 @@
         </p:nvSpPr>
         <p:spPr>
           <a:xfrm>
-            <a:off x="1382649" y="4564639"/>
+            <a:off x="1527742" y="4751862"/>
             <a:ext cx="274320" cy="274320"/>
           </a:xfrm>
           <a:prstGeom prst="ellipse">
@@ -51567,7 +51567,7 @@
         <p:spPr>
           <a:xfrm>
             <a:off x="388620" y="1165860"/>
-            <a:ext cx="6958584" cy="4846320"/>
+            <a:ext cx="7726680" cy="4846320"/>
           </a:xfrm>
           <a:prstGeom prst="rect">
             <a:avLst/>
@@ -51619,7 +51619,7 @@
         <p:spPr>
           <a:xfrm>
             <a:off x="411480" y="1188720"/>
-            <a:ext cx="6912864" cy="4800600"/>
+            <a:ext cx="7680960" cy="4800600"/>
           </a:xfrm>
           <a:prstGeom prst="rect">
             <a:avLst/>
@@ -51634,7 +51634,7 @@
         </p:nvSpPr>
         <p:spPr>
           <a:xfrm>
-            <a:off x="1382649" y="3019805"/>
+            <a:off x="1527742" y="3035647"/>
             <a:ext cx="274320" cy="274320"/>
           </a:xfrm>
           <a:prstGeom prst="ellipse">
@@ -51693,7 +51693,7 @@
         </p:nvSpPr>
         <p:spPr>
           <a:xfrm>
-            <a:off x="1382649" y="3319843"/>
+            <a:off x="1527742" y="3369289"/>
             <a:ext cx="274320" cy="274320"/>
           </a:xfrm>
           <a:prstGeom prst="ellipse">
@@ -51752,7 +51752,7 @@
         </p:nvSpPr>
         <p:spPr>
           <a:xfrm>
-            <a:off x="1382649" y="3779740"/>
+            <a:off x="1527742" y="3880073"/>
             <a:ext cx="274320" cy="274320"/>
           </a:xfrm>
           <a:prstGeom prst="ellipse">
@@ -51811,7 +51811,7 @@
         </p:nvSpPr>
         <p:spPr>
           <a:xfrm>
-            <a:off x="1382649" y="4564639"/>
+            <a:off x="1527742" y="4751862"/>
             <a:ext cx="274320" cy="274320"/>
           </a:xfrm>
           <a:prstGeom prst="ellipse">
@@ -52668,7 +52668,7 @@
         <p:spPr>
           <a:xfrm>
             <a:off x="411480" y="6062472"/>
-            <a:ext cx="6912864" cy="374904"/>
+            <a:ext cx="7680960" cy="374904"/>
           </a:xfrm>
           <a:prstGeom prst="rect">
             <a:avLst/>
@@ -52712,7 +52712,7 @@
         <p:spPr>
           <a:xfrm>
             <a:off x="576072" y="6126480"/>
-            <a:ext cx="6583680" cy="265176"/>
+            <a:ext cx="7351776" cy="265176"/>
           </a:xfrm>
           <a:prstGeom prst="rect">
             <a:avLst/>
@@ -53104,7 +53104,7 @@
         <p:spPr>
           <a:xfrm>
             <a:off x="388620" y="1165860"/>
-            <a:ext cx="6958584" cy="4846320"/>
+            <a:ext cx="7726680" cy="4846320"/>
           </a:xfrm>
           <a:prstGeom prst="rect">
             <a:avLst/>
@@ -53156,7 +53156,7 @@
         <p:spPr>
           <a:xfrm>
             <a:off x="411480" y="1188720"/>
-            <a:ext cx="6912864" cy="4800600"/>
+            <a:ext cx="7680960" cy="4800600"/>
           </a:xfrm>
           <a:prstGeom prst="rect">
             <a:avLst/>
@@ -53171,7 +53171,7 @@
         </p:nvSpPr>
         <p:spPr>
           <a:xfrm>
-            <a:off x="1464220" y="3382251"/>
+            <a:off x="1618377" y="3438418"/>
             <a:ext cx="274320" cy="274320"/>
           </a:xfrm>
           <a:prstGeom prst="ellipse">
@@ -55321,7 +55321,7 @@
         <p:spPr>
           <a:xfrm>
             <a:off x="388620" y="1165860"/>
-            <a:ext cx="6958584" cy="4846320"/>
+            <a:ext cx="7726680" cy="4846320"/>
           </a:xfrm>
           <a:prstGeom prst="rect">
             <a:avLst/>
@@ -55373,7 +55373,7 @@
         <p:spPr>
           <a:xfrm>
             <a:off x="411480" y="1188720"/>
-            <a:ext cx="6912864" cy="4800600"/>
+            <a:ext cx="7680960" cy="4800600"/>
           </a:xfrm>
           <a:prstGeom prst="rect">
             <a:avLst/>
@@ -55388,7 +55388,7 @@
         </p:nvSpPr>
         <p:spPr>
           <a:xfrm>
-            <a:off x="2841954" y="3844069"/>
+            <a:off x="3149193" y="3621321"/>
             <a:ext cx="274320" cy="274320"/>
           </a:xfrm>
           <a:prstGeom prst="ellipse">
@@ -55447,7 +55447,7 @@
         </p:nvSpPr>
         <p:spPr>
           <a:xfrm>
-            <a:off x="5441882" y="3535870"/>
+            <a:off x="6038002" y="3278558"/>
             <a:ext cx="274320" cy="274320"/>
           </a:xfrm>
           <a:prstGeom prst="ellipse">
@@ -55506,7 +55506,7 @@
         </p:nvSpPr>
         <p:spPr>
           <a:xfrm>
-            <a:off x="1440025" y="4174350"/>
+            <a:off x="1591494" y="3988087"/>
             <a:ext cx="274320" cy="274320"/>
           </a:xfrm>
           <a:prstGeom prst="ellipse">
@@ -55565,7 +55565,7 @@
         </p:nvSpPr>
         <p:spPr>
           <a:xfrm>
-            <a:off x="2841954" y="5506516"/>
+            <a:off x="3149193" y="5468112"/>
             <a:ext cx="274320" cy="274320"/>
           </a:xfrm>
           <a:prstGeom prst="ellipse">
@@ -65913,7 +65913,7 @@
                 </a:solidFill>
                 <a:latin typeface="Calibri"/>
               </a:rPr>
-              <a:t>This deck describes the application at commit f9f9068. If a screen has changed, the deck is wrong and not the application — raise it so this can be recaptured.</a:t>
+              <a:t>This deck describes the application at commit 37f71d3. If a screen has changed, the deck is wrong and not the application — raise it so this can be recaptured.</a:t>
             </a:r>
           </a:p>
           <a:p>

</xml_diff>